<commit_message>
feat(apollo-pptx): マスタースライド刷新 tune_master を導入 (v6.14)
- tune_master(template_path) を新設: テーマ色をクリムゾン・エディトリアルに刷新
  (accent1=C51212/グレー階調→ネイティブチャート既定色が自動ブランド化)、テーマ
  フォントを major:Yu Mincho / minor:Yu Gothic に、マスターへ天辺0.022inクリムゾン
  ヘアライン(BrandHairline)を挿入。白コンテンツ頁全部に署名が自動継承される。
- _hide_master(slide) を新設し、暗背景スライド(表紙/章扉/3点ステートメント/暗赤頁)
  で showMasterSp="0" を設定。黒頁に赤線が透けない。
- リポジトリのテンプレート apollo_template.pptx に適用済み。
- 4アーキタイプ設計思考(表紙/コンテンツ/章扉/結論)を SKILL.md に明文化。

https://claude.ai/code/session_01VUchd4fwU4ezbyD4d8joCn
</commit_message>
<xml_diff>
--- a/capcom_schema/templates/apollo_template.pptx
+++ b/capcom_schema/templates/apollo_template.pptx
@@ -2799,6 +2799,34 @@
             </a:fld>
             <a:endParaRPr lang="en-US"/>
           </a:p>
+        </p:txBody>
+      </p:sp>
+      <p:sp>
+        <p:nvSpPr>
+          <p:cNvPr id="900" name="BrandHairline"/>
+          <p:cNvSpPr/>
+          <p:nvPr/>
+        </p:nvSpPr>
+        <p:spPr>
+          <a:xfrm>
+            <a:off x="0" y="0"/>
+            <a:ext cx="12192000" cy="20320"/>
+          </a:xfrm>
+          <a:prstGeom prst="rect">
+            <a:avLst/>
+          </a:prstGeom>
+          <a:solidFill>
+            <a:srgbClr val="C51212"/>
+          </a:solidFill>
+          <a:ln>
+            <a:noFill/>
+          </a:ln>
+          <a:effectLst/>
+        </p:spPr>
+        <p:txBody>
+          <a:bodyPr/>
+          <a:lstStyle/>
+          <a:p/>
         </p:txBody>
       </p:sp>
     </p:spTree>
@@ -3080,46 +3108,46 @@
   <a:themeElements>
     <a:clrScheme name="APOLLO CAPCOM">
       <a:dk1>
-        <a:srgbClr val="1B2A4A"/>
+        <a:srgbClr val="111111"/>
       </a:dk1>
       <a:lt1>
         <a:srgbClr val="FFFFFF"/>
       </a:lt1>
       <a:dk2>
-        <a:srgbClr val="333333"/>
+        <a:srgbClr val="831010"/>
       </a:dk2>
       <a:lt2>
-        <a:srgbClr val="F5F5F5"/>
+        <a:srgbClr val="F6F7F8"/>
       </a:lt2>
       <a:accent1>
-        <a:srgbClr val="3B7DD8"/>
+        <a:srgbClr val="C51212"/>
       </a:accent1>
       <a:accent2>
-        <a:srgbClr val="2E5090"/>
+        <a:srgbClr val="4D5055"/>
       </a:accent2>
       <a:accent3>
-        <a:srgbClr val="2E8B57"/>
+        <a:srgbClr val="8F9499"/>
       </a:accent3>
       <a:accent4>
-        <a:srgbClr val="D4A017"/>
+        <a:srgbClr val="C7CBD0"/>
       </a:accent4>
       <a:accent5>
-        <a:srgbClr val="D64545"/>
+        <a:srgbClr val="831010"/>
       </a:accent5>
       <a:accent6>
-        <a:srgbClr val="666666"/>
+        <a:srgbClr val="E33333"/>
       </a:accent6>
       <a:hlink>
-        <a:srgbClr val="3B7DD8"/>
+        <a:srgbClr val="C51212"/>
       </a:hlink>
       <a:folHlink>
-        <a:srgbClr val="666666"/>
+        <a:srgbClr val="831010"/>
       </a:folHlink>
     </a:clrScheme>
     <a:fontScheme name="APOLLO CAPCOM">
       <a:majorFont>
-        <a:latin typeface="Hiragino Sans"/>
-        <a:ea typeface="Hiragino Sans"/>
+        <a:latin typeface="Century Gothic"/>
+        <a:ea typeface="Yu Mincho"/>
         <a:cs typeface=""/>
         <a:font script="Jpan" typeface="Hiragino Sans"/>
         <a:font script="Hang" typeface="맑은 고딕"/>
@@ -3153,8 +3181,8 @@
         <a:font script="Geor" typeface="Sylfaen"/>
       </a:majorFont>
       <a:minorFont>
-        <a:latin typeface="Hiragino Sans"/>
-        <a:ea typeface="Hiragino Sans"/>
+        <a:latin typeface="Century Gothic"/>
+        <a:ea typeface="Yu Gothic"/>
         <a:cs typeface=""/>
         <a:font script="Jpan" typeface="Hiragino Sans"/>
         <a:font script="Hang" typeface="맑은 고딕"/>

</xml_diff>